<commit_message>
feat: add embedded server capability to tariff optimization notebook
</commit_message>
<xml_diff>
--- a/app/OP26_Analytics_Presentation.pptx
+++ b/app/OP26_Analytics_Presentation.pptx
@@ -12,6 +12,7 @@
     <p:sldId id="260" r:id="rId11"/>
     <p:sldId id="261" r:id="rId12"/>
     <p:sldId id="262" r:id="rId13"/>
+    <p:sldId id="263" r:id="rId14"/>
   </p:sldIdLst>
   <p:sldSz cx="12191695" cy="6858000" type="screen4x3"/>
   <p:notesSz cx="6858000" cy="9144000"/>
@@ -3263,7 +3264,7 @@
               </a:defRPr>
             </a:pPr>
             <a:r>
-              <a:t>EV TARIFF OPTIMIZATION</a:t>
+              <a:t>PROJECT OVERVIEW</a:t>
             </a:r>
           </a:p>
         </p:txBody>
@@ -3299,7 +3300,7 @@
               </a:defRPr>
             </a:pPr>
             <a:r>
-              <a:t>Data Preprocessing &amp; Feature Engineering</a:t>
+              <a:t>Project Overview &amp; Objectives</a:t>
             </a:r>
           </a:p>
         </p:txBody>
@@ -3313,7 +3314,7 @@
         <p:spPr>
           <a:xfrm>
             <a:off x="731520" y="1645920"/>
-            <a:ext cx="5120640" cy="4389120"/>
+            <a:ext cx="10698480" cy="4389120"/>
           </a:xfrm>
           <a:prstGeom prst="rect">
             <a:avLst/>
@@ -3338,7 +3339,7 @@
               </a:defRPr>
             </a:pPr>
             <a:r>
-              <a:t>Data Cleaning &amp; Alignment</a:t>
+              <a:t>Dynamic Tariff Optimization Problem Setup</a:t>
             </a:r>
           </a:p>
           <a:p>
@@ -3346,7 +3347,7 @@
               <a:spcAft>
                 <a:spcPts val="1200"/>
               </a:spcAft>
-              <a:defRPr sz="1300">
+              <a:defRPr sz="1400">
                 <a:solidFill>
                   <a:srgbClr val="F1F5F9"/>
                 </a:solidFill>
@@ -3354,7 +3355,7 @@
               </a:defRPr>
             </a:pPr>
             <a:r>
-              <a:t>• ACN Dataset: Cleaned session data and forward-filled charging metrics into nested user update sheets.</a:t>
+              <a:t>• Problem Statement: Flat-rate tariffs cause peak-hour congestion and underutilization in off-peak windows.</a:t>
             </a:r>
           </a:p>
           <a:p>
@@ -3362,7 +3363,7 @@
               <a:spcAft>
                 <a:spcPts val="1200"/>
               </a:spcAft>
-              <a:defRPr sz="1300">
+              <a:defRPr sz="1400">
                 <a:solidFill>
                   <a:srgbClr val="F1F5F9"/>
                 </a:solidFill>
@@ -3370,7 +3371,7 @@
               </a:defRPr>
             </a:pPr>
             <a:r>
-              <a:t>• ACN Dataset: Aggregated session-level metrics into hourly active occupancies and charging loads.</a:t>
+              <a:t>• Objective: Build a self-improving pricing engine that autonomously predicts demand, optimizes tariffs, and learns from outcomes to maximize revenue and balance grid load.</a:t>
             </a:r>
           </a:p>
           <a:p>
@@ -3378,7 +3379,7 @@
               <a:spcAft>
                 <a:spcPts val="1200"/>
               </a:spcAft>
-              <a:defRPr sz="1300">
+              <a:defRPr sz="1400">
                 <a:solidFill>
                   <a:srgbClr val="F1F5F9"/>
                 </a:solidFill>
@@ -3386,126 +3387,7 @@
               </a:defRPr>
             </a:pPr>
             <a:r>
-              <a:t>• UrbanEV: Reshaped 2.13M row grid matrix datasets into long format for temporal-spatial training.</a:t>
-            </a:r>
-          </a:p>
-          <a:p>
-            <a:pPr>
-              <a:spcAft>
-                <a:spcPts val="1200"/>
-              </a:spcAft>
-              <a:defRPr sz="1300">
-                <a:solidFill>
-                  <a:srgbClr val="F1F5F9"/>
-                </a:solidFill>
-                <a:latin typeface="Inter"/>
-              </a:defRPr>
-            </a:pPr>
-            <a:r>
-              <a:t>• Unified Grid Scaling: Multiplied default price by 15.0 to align prices with Indian Rupee baseline metrics (average ~₹14.38/kWh).</a:t>
-            </a:r>
-          </a:p>
-        </p:txBody>
-      </p:sp>
-      <p:sp>
-        <p:nvSpPr>
-          <p:cNvPr id="5" name="TextBox 4"/>
-          <p:cNvSpPr txBox="1"/>
-          <p:nvPr/>
-        </p:nvSpPr>
-        <p:spPr>
-          <a:xfrm>
-            <a:off x="6217920" y="1645920"/>
-            <a:ext cx="5120640" cy="4389120"/>
-          </a:xfrm>
-          <a:prstGeom prst="rect">
-            <a:avLst/>
-          </a:prstGeom>
-          <a:noFill/>
-        </p:spPr>
-        <p:txBody>
-          <a:bodyPr wrap="square">
-            <a:spAutoFit/>
-          </a:bodyPr>
-          <a:lstStyle/>
-          <a:p>
-            <a:pPr>
-              <a:spcAft>
-                <a:spcPts val="1400"/>
-              </a:spcAft>
-              <a:defRPr sz="2000" b="1">
-                <a:solidFill>
-                  <a:srgbClr val="3B82F6"/>
-                </a:solidFill>
-                <a:latin typeface="Outfit"/>
-              </a:defRPr>
-            </a:pPr>
-            <a:r>
-              <a:t>Feature Engineering Decisions</a:t>
-            </a:r>
-          </a:p>
-          <a:p>
-            <a:pPr>
-              <a:spcAft>
-                <a:spcPts val="1200"/>
-              </a:spcAft>
-              <a:defRPr sz="1300">
-                <a:solidFill>
-                  <a:srgbClr val="F1F5F9"/>
-                </a:solidFill>
-                <a:latin typeface="Inter"/>
-              </a:defRPr>
-            </a:pPr>
-            <a:r>
-              <a:t>• Charger Utilization Rate: Computed as active charging time divided by total available capacity.</a:t>
-            </a:r>
-          </a:p>
-          <a:p>
-            <a:pPr>
-              <a:spcAft>
-                <a:spcPts val="1200"/>
-              </a:spcAft>
-              <a:defRPr sz="1300">
-                <a:solidFill>
-                  <a:srgbClr val="F1F5F9"/>
-                </a:solidFill>
-                <a:latin typeface="Inter"/>
-              </a:defRPr>
-            </a:pPr>
-            <a:r>
-              <a:t>• Queue Length Proxy: Defined as max(0, Occupancy - Capacity) to estimate queue congestion at peak intervals.</a:t>
-            </a:r>
-          </a:p>
-          <a:p>
-            <a:pPr>
-              <a:spcAft>
-                <a:spcPts val="1200"/>
-              </a:spcAft>
-              <a:defRPr sz="1300">
-                <a:solidFill>
-                  <a:srgbClr val="F1F5F9"/>
-                </a:solidFill>
-                <a:latin typeface="Inter"/>
-              </a:defRPr>
-            </a:pPr>
-            <a:r>
-              <a:t>• Occupancy Density: Normalized grid occupancies per square kilometer.</a:t>
-            </a:r>
-          </a:p>
-          <a:p>
-            <a:pPr>
-              <a:spcAft>
-                <a:spcPts val="1200"/>
-              </a:spcAft>
-              <a:defRPr sz="1300">
-                <a:solidFill>
-                  <a:srgbClr val="F1F5F9"/>
-                </a:solidFill>
-                <a:latin typeface="Inter"/>
-              </a:defRPr>
-            </a:pPr>
-            <a:r>
-              <a:t>• Time-Series Lags: Engineered 1-hour, 2-hour, and 24-hour lags, alongside 3-hour rolling averages, to capture temporal patterns.</a:t>
+              <a:t>• Datasets: Caltech ACN-Data (30,000+ sessions) and Shenzhen UrbanEV Dataset (24,798 charging piles).</a:t>
             </a:r>
           </a:p>
         </p:txBody>
@@ -3603,7 +3485,7 @@
               </a:defRPr>
             </a:pPr>
             <a:r>
-              <a:t>Exploratory Data Analysis (EDA)</a:t>
+              <a:t>Data Preprocessing &amp; Feature Engineering</a:t>
             </a:r>
           </a:p>
         </p:txBody>
@@ -3642,7 +3524,7 @@
               </a:defRPr>
             </a:pPr>
             <a:r>
-              <a:t>Temporal &amp; Spatial Insights</a:t>
+              <a:t>Data Cleaning &amp; Alignment</a:t>
             </a:r>
           </a:p>
           <a:p>
@@ -3658,7 +3540,7 @@
               </a:defRPr>
             </a:pPr>
             <a:r>
-              <a:t>• Workplace Patterns (ACN Caltech): Strong charging demand peaks during weekday business hours (8 AM - 4 PM), collapsing to near-zero on weekends.</a:t>
+              <a:t>• ACN Dataset: Cleaned session data and forward-filled charging metrics into nested user update sheets.</a:t>
             </a:r>
           </a:p>
           <a:p>
@@ -3674,7 +3556,7 @@
               </a:defRPr>
             </a:pPr>
             <a:r>
-              <a:t>• Public Urban Grids (UrbanEV Shenzhen): Bimodal demand peaks around morning commute (8 AM - 10 AM) and early evening (6 PM - 9 PM) as taxis and public fleets recharge.</a:t>
+              <a:t>• ACN Dataset: Aggregated session-level metrics into hourly active occupancies and charging loads.</a:t>
             </a:r>
           </a:p>
           <a:p>
@@ -3690,7 +3572,23 @@
               </a:defRPr>
             </a:pPr>
             <a:r>
-              <a:t>• Congestion Inefficiency: Flat baseline pricing (fixed ₹15/kWh) fails to represent operational strain, leading to severe localized queues during peak hours while chargers sit idle off-peak.</a:t>
+              <a:t>• UrbanEV: Reshaped 2.13M row grid matrix datasets into long format for temporal-spatial training.</a:t>
+            </a:r>
+          </a:p>
+          <a:p>
+            <a:pPr>
+              <a:spcAft>
+                <a:spcPts val="1200"/>
+              </a:spcAft>
+              <a:defRPr sz="1300">
+                <a:solidFill>
+                  <a:srgbClr val="F1F5F9"/>
+                </a:solidFill>
+                <a:latin typeface="Inter"/>
+              </a:defRPr>
+            </a:pPr>
+            <a:r>
+              <a:t>• Unified Grid Scaling: Multiplied default price by 15.0 to align prices with Indian Rupee baseline metrics (average ~₹14.38/kWh).</a:t>
             </a:r>
           </a:p>
         </p:txBody>
@@ -3729,15 +3627,15 @@
               </a:defRPr>
             </a:pPr>
             <a:r>
-              <a:t>Pricing Integration Hook</a:t>
+              <a:t>Feature Engineering Decisions</a:t>
             </a:r>
           </a:p>
           <a:p>
             <a:pPr>
               <a:spcAft>
-                <a:spcPts val="1400"/>
+                <a:spcPts val="1200"/>
               </a:spcAft>
-              <a:defRPr sz="1400">
+              <a:defRPr sz="1300">
                 <a:solidFill>
                   <a:srgbClr val="F1F5F9"/>
                 </a:solidFill>
@@ -3745,20 +3643,55 @@
               </a:defRPr>
             </a:pPr>
             <a:r>
-              <a:t>An interactive visual chart showing average daily profiles is embedded in the web dashboard console, highlighting the peak volatility between weekday work commutes and evening grid peaks.</a:t>
-            </a:r>
-          </a:p>
-          <a:p>
-            <a:pPr>
-              <a:defRPr sz="1300" i="1">
-                <a:solidFill>
-                  <a:srgbClr val="94A3B8"/>
+              <a:t>• Charger Utilization Rate: Computed as active charging time divided by total available capacity.</a:t>
+            </a:r>
+          </a:p>
+          <a:p>
+            <a:pPr>
+              <a:spcAft>
+                <a:spcPts val="1200"/>
+              </a:spcAft>
+              <a:defRPr sz="1300">
+                <a:solidFill>
+                  <a:srgbClr val="F1F5F9"/>
                 </a:solidFill>
                 <a:latin typeface="Inter"/>
               </a:defRPr>
             </a:pPr>
             <a:r>
-              <a:t>Grid demand is highly elastic if priced correctly. Shifts in pricing directly affect charger utilization rate during off-peak windows.</a:t>
+              <a:t>• Queue Length Proxy: Defined as max(0, Occupancy - Capacity) to estimate queue congestion at peak intervals.</a:t>
+            </a:r>
+          </a:p>
+          <a:p>
+            <a:pPr>
+              <a:spcAft>
+                <a:spcPts val="1200"/>
+              </a:spcAft>
+              <a:defRPr sz="1300">
+                <a:solidFill>
+                  <a:srgbClr val="F1F5F9"/>
+                </a:solidFill>
+                <a:latin typeface="Inter"/>
+              </a:defRPr>
+            </a:pPr>
+            <a:r>
+              <a:t>• Occupancy Density: Normalized grid occupancies per square kilometer.</a:t>
+            </a:r>
+          </a:p>
+          <a:p>
+            <a:pPr>
+              <a:spcAft>
+                <a:spcPts val="1200"/>
+              </a:spcAft>
+              <a:defRPr sz="1300">
+                <a:solidFill>
+                  <a:srgbClr val="F1F5F9"/>
+                </a:solidFill>
+                <a:latin typeface="Inter"/>
+              </a:defRPr>
+            </a:pPr>
+            <a:r>
+              <a:t>• Time-Series Lags: Engineered 1-hour, 2-hour, and 24-hour lags, alongside 3-hour rolling averages, to capture temporal patterns.</a:t>
             </a:r>
           </a:p>
         </p:txBody>
@@ -3856,7 +3789,7 @@
               </a:defRPr>
             </a:pPr>
             <a:r>
-              <a:t>Demand Prediction Agent</a:t>
+              <a:t>Exploratory Data Analysis (EDA)</a:t>
             </a:r>
           </a:p>
         </p:txBody>
@@ -3895,7 +3828,7 @@
               </a:defRPr>
             </a:pPr>
             <a:r>
-              <a:t>Forecasting Methodology</a:t>
+              <a:t>Temporal &amp; Spatial Insights</a:t>
             </a:r>
           </a:p>
           <a:p>
@@ -3911,7 +3844,7 @@
               </a:defRPr>
             </a:pPr>
             <a:r>
-              <a:t>• LightGBM Regressors: Trained separate models to predict charging occupancy and volume (expected load) simultaneously.</a:t>
+              <a:t>• Workplace Patterns (ACN Caltech): Strong charging demand peaks during weekday business hours (8 AM - 4 PM), collapsing to near-zero on weekends.</a:t>
             </a:r>
           </a:p>
           <a:p>
@@ -3927,7 +3860,7 @@
               </a:defRPr>
             </a:pPr>
             <a:r>
-              <a:t>• Lag &amp; Rolling Windows: Utilized temporal features (hour, day, weekend markers) alongside historical load lags to capture auto-regressive properties.</a:t>
+              <a:t>• Public Urban Grids (UrbanEV Shenzhen): Bimodal demand peaks around morning commute (8 AM - 10 AM) and early evening (6 PM - 9 PM) as taxis and public fleets recharge.</a:t>
             </a:r>
           </a:p>
           <a:p>
@@ -3943,198 +3876,35 @@
               </a:defRPr>
             </a:pPr>
             <a:r>
-              <a:t>• Congestion Probability: Calculated using a sigmoid activation function centered around 80% utilization rate, warning operators of overload risks in real time.</a:t>
-            </a:r>
-          </a:p>
-        </p:txBody>
-      </p:sp>
-      <p:sp>
-        <p:nvSpPr>
-          <p:cNvPr id="5" name="TextBox 4"/>
-          <p:cNvSpPr txBox="1"/>
+              <a:t>• Congestion Inefficiency: Flat baseline pricing (fixed ₹15/kWh) fails to represent operational strain, leading to severe localized queues during peak hours while chargers sit idle off-peak.</a:t>
+            </a:r>
+          </a:p>
+        </p:txBody>
+      </p:sp>
+      <p:pic>
+        <p:nvPicPr>
+          <p:cNvPr id="5" name="Picture 4" descr="eda_profile.png"/>
+          <p:cNvPicPr>
+            <a:picLocks noChangeAspect="1"/>
+          </p:cNvPicPr>
           <p:nvPr/>
-        </p:nvSpPr>
+        </p:nvPicPr>
+        <p:blipFill>
+          <a:blip r:embed="rId2"/>
+          <a:stretch>
+            <a:fillRect/>
+          </a:stretch>
+        </p:blipFill>
         <p:spPr>
           <a:xfrm>
             <a:off x="6217920" y="1645920"/>
-            <a:ext cx="5120640" cy="4389120"/>
+            <a:ext cx="5120640" cy="3383280"/>
           </a:xfrm>
           <a:prstGeom prst="rect">
             <a:avLst/>
           </a:prstGeom>
-          <a:noFill/>
         </p:spPr>
-        <p:txBody>
-          <a:bodyPr wrap="square">
-            <a:spAutoFit/>
-          </a:bodyPr>
-          <a:lstStyle/>
-          <a:p>
-            <a:pPr>
-              <a:spcAft>
-                <a:spcPts val="1400"/>
-              </a:spcAft>
-              <a:defRPr sz="2000" b="1">
-                <a:solidFill>
-                  <a:srgbClr val="3B82F6"/>
-                </a:solidFill>
-                <a:latin typeface="Outfit"/>
-              </a:defRPr>
-            </a:pPr>
-            <a:r>
-              <a:t>Model Evaluation Performance</a:t>
-            </a:r>
-          </a:p>
-          <a:p>
-            <a:pPr>
-              <a:defRPr sz="1300" b="1">
-                <a:solidFill>
-                  <a:srgbClr val="F1F5F9"/>
-                </a:solidFill>
-                <a:latin typeface="Inter"/>
-              </a:defRPr>
-            </a:pPr>
-            <a:r>
-              <a:t>UrbanEV Occupancy R²: </a:t>
-            </a:r>
-            <a:r>
-              <a:rPr b="1">
-                <a:solidFill>
-                  <a:srgbClr val="10B981"/>
-                </a:solidFill>
-              </a:rPr>
-              <a:t>98.68%</a:t>
-            </a:r>
-          </a:p>
-          <a:p>
-            <a:pPr>
-              <a:spcAft>
-                <a:spcPts val="800"/>
-              </a:spcAft>
-              <a:defRPr sz="1100">
-                <a:solidFill>
-                  <a:srgbClr val="94A3B8"/>
-                </a:solidFill>
-                <a:latin typeface="Inter"/>
-              </a:defRPr>
-            </a:pPr>
-            <a:r>
-              <a:t>  - Highly predictive spatial-temporal consistency</a:t>
-            </a:r>
-          </a:p>
-          <a:p>
-            <a:pPr>
-              <a:defRPr sz="1300" b="1">
-                <a:solidFill>
-                  <a:srgbClr val="F1F5F9"/>
-                </a:solidFill>
-                <a:latin typeface="Inter"/>
-              </a:defRPr>
-            </a:pPr>
-            <a:r>
-              <a:t>UrbanEV Charging Volume R²: </a:t>
-            </a:r>
-            <a:r>
-              <a:rPr b="1">
-                <a:solidFill>
-                  <a:srgbClr val="10B981"/>
-                </a:solidFill>
-              </a:rPr>
-              <a:t>91.07%</a:t>
-            </a:r>
-          </a:p>
-          <a:p>
-            <a:pPr>
-              <a:spcAft>
-                <a:spcPts val="800"/>
-              </a:spcAft>
-              <a:defRPr sz="1100">
-                <a:solidFill>
-                  <a:srgbClr val="94A3B8"/>
-                </a:solidFill>
-                <a:latin typeface="Inter"/>
-              </a:defRPr>
-            </a:pPr>
-            <a:r>
-              <a:t>  - Robust regression over aggregated loads</a:t>
-            </a:r>
-          </a:p>
-          <a:p>
-            <a:pPr>
-              <a:defRPr sz="1300" b="1">
-                <a:solidFill>
-                  <a:srgbClr val="F1F5F9"/>
-                </a:solidFill>
-                <a:latin typeface="Inter"/>
-              </a:defRPr>
-            </a:pPr>
-            <a:r>
-              <a:t>ACN Occupancy R²: </a:t>
-            </a:r>
-            <a:r>
-              <a:rPr b="1">
-                <a:solidFill>
-                  <a:srgbClr val="10B981"/>
-                </a:solidFill>
-              </a:rPr>
-              <a:t>95.24%</a:t>
-            </a:r>
-          </a:p>
-          <a:p>
-            <a:pPr>
-              <a:spcAft>
-                <a:spcPts val="800"/>
-              </a:spcAft>
-              <a:defRPr sz="1100">
-                <a:solidFill>
-                  <a:srgbClr val="94A3B8"/>
-                </a:solidFill>
-                <a:latin typeface="Inter"/>
-              </a:defRPr>
-            </a:pPr>
-            <a:r>
-              <a:t>  - Predictive accuracy over workplace schedules</a:t>
-            </a:r>
-          </a:p>
-          <a:p>
-            <a:pPr>
-              <a:defRPr sz="1300" b="1">
-                <a:solidFill>
-                  <a:srgbClr val="F1F5F9"/>
-                </a:solidFill>
-                <a:latin typeface="Inter"/>
-              </a:defRPr>
-            </a:pPr>
-            <a:r>
-              <a:t>ACN Charging Volume R²: </a:t>
-            </a:r>
-            <a:r>
-              <a:rPr b="1">
-                <a:solidFill>
-                  <a:srgbClr val="10B981"/>
-                </a:solidFill>
-              </a:rPr>
-              <a:t>80.57%</a:t>
-            </a:r>
-          </a:p>
-          <a:p>
-            <a:pPr>
-              <a:spcAft>
-                <a:spcPts val="800"/>
-              </a:spcAft>
-              <a:defRPr sz="1100">
-                <a:solidFill>
-                  <a:srgbClr val="94A3B8"/>
-                </a:solidFill>
-                <a:latin typeface="Inter"/>
-              </a:defRPr>
-            </a:pPr>
-            <a:r>
-              <a:t>  - Captures high-volatility session curves</a:t>
-            </a:r>
-          </a:p>
-        </p:txBody>
-      </p:sp>
+      </p:pic>
     </p:spTree>
   </p:cSld>
   <p:clrMapOvr>
@@ -4228,7 +3998,7 @@
               </a:defRPr>
             </a:pPr>
             <a:r>
-              <a:t>Tariff Pricing Agent</a:t>
+              <a:t>Demand Prediction Agent</a:t>
             </a:r>
           </a:p>
         </p:txBody>
@@ -4267,7 +4037,7 @@
               </a:defRPr>
             </a:pPr>
             <a:r>
-              <a:t>Dynamic Tariff Logic</a:t>
+              <a:t>Forecasting Methodology</a:t>
             </a:r>
           </a:p>
           <a:p>
@@ -4283,7 +4053,7 @@
               </a:defRPr>
             </a:pPr>
             <a:r>
-              <a:t>• Surge Pricing Boundary: Triggered when predicted station utilization exceeds 80%. Linearly scales tariff from baseline (₹15/kWh) up to max cap (₹25/kWh).</a:t>
+              <a:t>• LightGBM Regressors: Trained separate models to predict charging occupancy and volume (expected load) simultaneously.</a:t>
             </a:r>
           </a:p>
           <a:p>
@@ -4299,7 +4069,7 @@
               </a:defRPr>
             </a:pPr>
             <a:r>
-              <a:t>• Discount Pricing Boundary: Triggered when predicted station utilization drops below 30%. Linearly decreases tariff from baseline down to floor (₹10/kWh).</a:t>
+              <a:t>• Lag &amp; Rolling Windows: Utilized temporal features (hour, day, weekend markers) alongside historical load lags to capture auto-regressive properties.</a:t>
             </a:r>
           </a:p>
           <a:p>
@@ -4315,7 +4085,7 @@
               </a:defRPr>
             </a:pPr>
             <a:r>
-              <a:t>• Fixed Baseline Pricing: Holds pricing flat at ₹15/kWh for normal occupancy states (30% to 80% utilization).</a:t>
+              <a:t>• Congestion Probability: Calculated using a sigmoid activation function centered around 80% utilization rate, warning operators of overload risks in real time.</a:t>
             </a:r>
           </a:p>
         </p:txBody>
@@ -4354,7 +4124,28 @@
               </a:defRPr>
             </a:pPr>
             <a:r>
-              <a:t>Simulating User Demand Elasticity</a:t>
+              <a:t>Model Evaluation Performance</a:t>
+            </a:r>
+          </a:p>
+          <a:p>
+            <a:pPr>
+              <a:defRPr sz="1300" b="1">
+                <a:solidFill>
+                  <a:srgbClr val="F1F5F9"/>
+                </a:solidFill>
+                <a:latin typeface="Inter"/>
+              </a:defRPr>
+            </a:pPr>
+            <a:r>
+              <a:t>UrbanEV Occupancy R²: </a:t>
+            </a:r>
+            <a:r>
+              <a:rPr b="1">
+                <a:solidFill>
+                  <a:srgbClr val="10B981"/>
+                </a:solidFill>
+              </a:rPr>
+              <a:t>98.68%</a:t>
             </a:r>
           </a:p>
           <a:p>
@@ -4362,7 +4153,20 @@
               <a:spcAft>
                 <a:spcPts val="800"/>
               </a:spcAft>
-              <a:defRPr sz="1300">
+              <a:defRPr sz="1100">
+                <a:solidFill>
+                  <a:srgbClr val="94A3B8"/>
+                </a:solidFill>
+                <a:latin typeface="Inter"/>
+              </a:defRPr>
+            </a:pPr>
+            <a:r>
+              <a:t>  - Highly predictive spatial-temporal consistency</a:t>
+            </a:r>
+          </a:p>
+          <a:p>
+            <a:pPr>
+              <a:defRPr sz="1300" b="1">
                 <a:solidFill>
                   <a:srgbClr val="F1F5F9"/>
                 </a:solidFill>
@@ -4370,23 +4174,15 @@
               </a:defRPr>
             </a:pPr>
             <a:r>
-              <a:t>Demand response is modeled using the price elasticity of demand coefficient:</a:t>
-            </a:r>
-          </a:p>
-          <a:p>
-            <a:pPr>
-              <a:spcAft>
-                <a:spcPts val="1400"/>
-              </a:spcAft>
-              <a:defRPr sz="1300" b="1">
+              <a:t>UrbanEV Charging Volume R²: </a:t>
+            </a:r>
+            <a:r>
+              <a:rPr b="1">
                 <a:solidFill>
                   <a:srgbClr val="10B981"/>
                 </a:solidFill>
-                <a:latin typeface="Courier New"/>
-              </a:defRPr>
-            </a:pPr>
-            <a:r>
-              <a:t>D_elastic = D_predicted * (1 - elasticity * (P_dynamic - P_baseline) / P_baseline)</a:t>
+              </a:rPr>
+              <a:t>91.07%</a:t>
             </a:r>
           </a:p>
           <a:p>
@@ -4394,7 +4190,20 @@
               <a:spcAft>
                 <a:spcPts val="800"/>
               </a:spcAft>
-              <a:defRPr sz="1300">
+              <a:defRPr sz="1100">
+                <a:solidFill>
+                  <a:srgbClr val="94A3B8"/>
+                </a:solidFill>
+                <a:latin typeface="Inter"/>
+              </a:defRPr>
+            </a:pPr>
+            <a:r>
+              <a:t>  - Robust regression over aggregated loads</a:t>
+            </a:r>
+          </a:p>
+          <a:p>
+            <a:pPr>
+              <a:defRPr sz="1300" b="1">
                 <a:solidFill>
                   <a:srgbClr val="F1F5F9"/>
                 </a:solidFill>
@@ -4402,7 +4211,15 @@
               </a:defRPr>
             </a:pPr>
             <a:r>
-              <a:t>• Peak Shaving: Incentivizes users with flexible schedules to delay charging during high surge cost windows.</a:t>
+              <a:t>ACN Occupancy R²: </a:t>
+            </a:r>
+            <a:r>
+              <a:rPr b="1">
+                <a:solidFill>
+                  <a:srgbClr val="10B981"/>
+                </a:solidFill>
+              </a:rPr>
+              <a:t>95.24%</a:t>
             </a:r>
           </a:p>
           <a:p>
@@ -4410,7 +4227,20 @@
               <a:spcAft>
                 <a:spcPts val="800"/>
               </a:spcAft>
-              <a:defRPr sz="1300">
+              <a:defRPr sz="1100">
+                <a:solidFill>
+                  <a:srgbClr val="94A3B8"/>
+                </a:solidFill>
+                <a:latin typeface="Inter"/>
+              </a:defRPr>
+            </a:pPr>
+            <a:r>
+              <a:t>  - Predictive accuracy over workplace schedules</a:t>
+            </a:r>
+          </a:p>
+          <a:p>
+            <a:pPr>
+              <a:defRPr sz="1300" b="1">
                 <a:solidFill>
                   <a:srgbClr val="F1F5F9"/>
                 </a:solidFill>
@@ -4418,7 +4248,31 @@
               </a:defRPr>
             </a:pPr>
             <a:r>
-              <a:t>• Off-peak Filling: Stimulates off-peak demand by offering dynamic discount tariffs.</a:t>
+              <a:t>ACN Charging Volume R²: </a:t>
+            </a:r>
+            <a:r>
+              <a:rPr b="1">
+                <a:solidFill>
+                  <a:srgbClr val="10B981"/>
+                </a:solidFill>
+              </a:rPr>
+              <a:t>80.57%</a:t>
+            </a:r>
+          </a:p>
+          <a:p>
+            <a:pPr>
+              <a:spcAft>
+                <a:spcPts val="800"/>
+              </a:spcAft>
+              <a:defRPr sz="1100">
+                <a:solidFill>
+                  <a:srgbClr val="94A3B8"/>
+                </a:solidFill>
+                <a:latin typeface="Inter"/>
+              </a:defRPr>
+            </a:pPr>
+            <a:r>
+              <a:t>  - Captures high-volatility session curves</a:t>
             </a:r>
           </a:p>
         </p:txBody>
@@ -4516,7 +4370,7 @@
               </a:defRPr>
             </a:pPr>
             <a:r>
-              <a:t>Monitoring &amp; Learning Agent</a:t>
+              <a:t>Tariff Pricing Agent</a:t>
             </a:r>
           </a:p>
         </p:txBody>
@@ -4555,6 +4409,267 @@
               </a:defRPr>
             </a:pPr>
             <a:r>
+              <a:t>Dynamic Tariff Logic</a:t>
+            </a:r>
+          </a:p>
+          <a:p>
+            <a:pPr>
+              <a:spcAft>
+                <a:spcPts val="1200"/>
+              </a:spcAft>
+              <a:defRPr sz="1300">
+                <a:solidFill>
+                  <a:srgbClr val="F1F5F9"/>
+                </a:solidFill>
+                <a:latin typeface="Inter"/>
+              </a:defRPr>
+            </a:pPr>
+            <a:r>
+              <a:t>• Surge Pricing Boundary: Triggered when predicted station utilization exceeds 80%. Linearly scales tariff from baseline (₹15/kWh) up to max cap (₹25/kWh).</a:t>
+            </a:r>
+          </a:p>
+          <a:p>
+            <a:pPr>
+              <a:spcAft>
+                <a:spcPts val="1200"/>
+              </a:spcAft>
+              <a:defRPr sz="1300">
+                <a:solidFill>
+                  <a:srgbClr val="F1F5F9"/>
+                </a:solidFill>
+                <a:latin typeface="Inter"/>
+              </a:defRPr>
+            </a:pPr>
+            <a:r>
+              <a:t>• Discount Pricing Boundary: Triggered when predicted station utilization drops below 30%. Linearly decreases tariff from baseline down to floor (₹10/kWh).</a:t>
+            </a:r>
+          </a:p>
+          <a:p>
+            <a:pPr>
+              <a:spcAft>
+                <a:spcPts val="1200"/>
+              </a:spcAft>
+              <a:defRPr sz="1300">
+                <a:solidFill>
+                  <a:srgbClr val="F1F5F9"/>
+                </a:solidFill>
+                <a:latin typeface="Inter"/>
+              </a:defRPr>
+            </a:pPr>
+            <a:r>
+              <a:t>• Fixed Baseline Pricing: Holds pricing flat at ₹15/kWh for normal occupancy states (30% to 80% utilization).</a:t>
+            </a:r>
+          </a:p>
+        </p:txBody>
+      </p:sp>
+      <p:sp>
+        <p:nvSpPr>
+          <p:cNvPr id="5" name="TextBox 4"/>
+          <p:cNvSpPr txBox="1"/>
+          <p:nvPr/>
+        </p:nvSpPr>
+        <p:spPr>
+          <a:xfrm>
+            <a:off x="6217920" y="1645920"/>
+            <a:ext cx="5120640" cy="1645920"/>
+          </a:xfrm>
+          <a:prstGeom prst="rect">
+            <a:avLst/>
+          </a:prstGeom>
+          <a:noFill/>
+        </p:spPr>
+        <p:txBody>
+          <a:bodyPr wrap="square" lIns="0" tIns="0">
+            <a:spAutoFit/>
+          </a:bodyPr>
+          <a:lstStyle/>
+          <a:p>
+            <a:pPr>
+              <a:spcAft>
+                <a:spcPts val="800"/>
+              </a:spcAft>
+              <a:defRPr sz="2000" b="1">
+                <a:solidFill>
+                  <a:srgbClr val="3B82F6"/>
+                </a:solidFill>
+                <a:latin typeface="Outfit"/>
+              </a:defRPr>
+            </a:pPr>
+            <a:r>
+              <a:t>Simulating User Demand Elasticity</a:t>
+            </a:r>
+          </a:p>
+          <a:p>
+            <a:pPr>
+              <a:defRPr sz="1200" b="1">
+                <a:solidFill>
+                  <a:srgbClr val="10B981"/>
+                </a:solidFill>
+                <a:latin typeface="Courier New"/>
+              </a:defRPr>
+            </a:pPr>
+            <a:r>
+              <a:t>D_elastic = D_predicted * (1 - elasticity * (P_dynamic - P_baseline) / P_baseline)</a:t>
+            </a:r>
+          </a:p>
+        </p:txBody>
+      </p:sp>
+      <p:pic>
+        <p:nvPicPr>
+          <p:cNvPr id="6" name="Picture 5" descr="simulation_results.png"/>
+          <p:cNvPicPr>
+            <a:picLocks noChangeAspect="1"/>
+          </p:cNvPicPr>
+          <p:nvPr/>
+        </p:nvPicPr>
+        <p:blipFill>
+          <a:blip r:embed="rId2"/>
+          <a:stretch>
+            <a:fillRect/>
+          </a:stretch>
+        </p:blipFill>
+        <p:spPr>
+          <a:xfrm>
+            <a:off x="6217920" y="2926080"/>
+            <a:ext cx="5120640" cy="3200400"/>
+          </a:xfrm>
+          <a:prstGeom prst="rect">
+            <a:avLst/>
+          </a:prstGeom>
+        </p:spPr>
+      </p:pic>
+    </p:spTree>
+  </p:cSld>
+  <p:clrMapOvr>
+    <a:masterClrMapping/>
+  </p:clrMapOvr>
+</p:sld>
+</file>
+
+<file path=ppt/slides/slide7.xml><?xml version="1.0" encoding="utf-8"?>
+<p:sld xmlns:a="http://schemas.openxmlformats.org/drawingml/2006/main" xmlns:p="http://schemas.openxmlformats.org/presentationml/2006/main" xmlns:r="http://schemas.openxmlformats.org/officeDocument/2006/relationships">
+  <p:cSld>
+    <p:bg>
+      <p:bgPr>
+        <a:solidFill>
+          <a:srgbClr val="060B13"/>
+        </a:solidFill>
+        <a:effectLst/>
+      </p:bgPr>
+    </p:bg>
+    <p:spTree>
+      <p:nvGrpSpPr>
+        <p:cNvPr id="1" name=""/>
+        <p:cNvGrpSpPr/>
+        <p:nvPr/>
+      </p:nvGrpSpPr>
+      <p:grpSpPr/>
+      <p:sp>
+        <p:nvSpPr>
+          <p:cNvPr id="2" name="TextBox 1"/>
+          <p:cNvSpPr txBox="1"/>
+          <p:nvPr/>
+        </p:nvSpPr>
+        <p:spPr>
+          <a:xfrm>
+            <a:off x="731520" y="365760"/>
+            <a:ext cx="10698480" cy="365760"/>
+          </a:xfrm>
+          <a:prstGeom prst="rect">
+            <a:avLst/>
+          </a:prstGeom>
+          <a:noFill/>
+        </p:spPr>
+        <p:txBody>
+          <a:bodyPr wrap="square">
+            <a:spAutoFit/>
+          </a:bodyPr>
+          <a:lstStyle/>
+          <a:p>
+            <a:pPr>
+              <a:defRPr sz="1000" b="1">
+                <a:solidFill>
+                  <a:srgbClr val="10B981"/>
+                </a:solidFill>
+                <a:latin typeface="Outfit"/>
+              </a:defRPr>
+            </a:pPr>
+            <a:r>
+              <a:t>EV TARIFF OPTIMIZATION</a:t>
+            </a:r>
+          </a:p>
+        </p:txBody>
+      </p:sp>
+      <p:sp>
+        <p:nvSpPr>
+          <p:cNvPr id="3" name="TextBox 2"/>
+          <p:cNvSpPr txBox="1"/>
+          <p:nvPr/>
+        </p:nvSpPr>
+        <p:spPr>
+          <a:xfrm>
+            <a:off x="731520" y="640080"/>
+            <a:ext cx="10698480" cy="731520"/>
+          </a:xfrm>
+          <a:prstGeom prst="rect">
+            <a:avLst/>
+          </a:prstGeom>
+          <a:noFill/>
+        </p:spPr>
+        <p:txBody>
+          <a:bodyPr wrap="square">
+            <a:spAutoFit/>
+          </a:bodyPr>
+          <a:lstStyle/>
+          <a:p>
+            <a:pPr>
+              <a:defRPr sz="2800" b="1">
+                <a:solidFill>
+                  <a:srgbClr val="F1F5F9"/>
+                </a:solidFill>
+                <a:latin typeface="Outfit"/>
+              </a:defRPr>
+            </a:pPr>
+            <a:r>
+              <a:t>Monitoring &amp; Learning Agent</a:t>
+            </a:r>
+          </a:p>
+        </p:txBody>
+      </p:sp>
+      <p:sp>
+        <p:nvSpPr>
+          <p:cNvPr id="4" name="TextBox 3"/>
+          <p:cNvSpPr txBox="1"/>
+          <p:nvPr/>
+        </p:nvSpPr>
+        <p:spPr>
+          <a:xfrm>
+            <a:off x="731520" y="1645920"/>
+            <a:ext cx="5120640" cy="4389120"/>
+          </a:xfrm>
+          <a:prstGeom prst="rect">
+            <a:avLst/>
+          </a:prstGeom>
+          <a:noFill/>
+        </p:spPr>
+        <p:txBody>
+          <a:bodyPr wrap="square">
+            <a:spAutoFit/>
+          </a:bodyPr>
+          <a:lstStyle/>
+          <a:p>
+            <a:pPr>
+              <a:spcAft>
+                <a:spcPts val="1400"/>
+              </a:spcAft>
+              <a:defRPr sz="2000" b="1">
+                <a:solidFill>
+                  <a:srgbClr val="3B82F6"/>
+                </a:solidFill>
+                <a:latin typeface="Outfit"/>
+              </a:defRPr>
+            </a:pPr>
+            <a:r>
               <a:t>Closed-Loop Feedback Loop</a:t>
             </a:r>
           </a:p>
@@ -4803,7 +4918,7 @@
 </p:sld>
 </file>
 
-<file path=ppt/slides/slide7.xml><?xml version="1.0" encoding="utf-8"?>
+<file path=ppt/slides/slide8.xml><?xml version="1.0" encoding="utf-8"?>
 <p:sld xmlns:a="http://schemas.openxmlformats.org/drawingml/2006/main" xmlns:p="http://schemas.openxmlformats.org/presentationml/2006/main" xmlns:r="http://schemas.openxmlformats.org/officeDocument/2006/relationships">
   <p:cSld>
     <p:bg>

</xml_diff>